<commit_message>
docs(demos): the cost slide shows hosting for prod, test and dev, and the SDLC tools
Hosting is three environments at about 1,000 euros a month each, 3,000
a month or 36,000 a year; SDLC and developer tools are named as a cost
line without a figure. The build card no longer lists hosting. Both
PPTX decks, the narrated web deck and its Spanish narration and Basque
subtitles for slide 9 carry the new figures.
</commit_message>
<xml_diff>
--- a/docs/demos/basque-ehds-15min.pptx
+++ b/docs/demos/basque-ehds-15min.pptx
@@ -1422,6 +1422,12 @@
               <a:t>For a regional pilot in the Basque Country we estimate 0.8 to 1.5 million euros to build. Operations then cost about 15 to 25 percent of that every year. That is roughly 120,000 to 375,000 euros a year.</a:t>
             </a:r>
           </a:p>
+          <a:p/>
+          <a:p>
+            <a:r>
+              <a:t>For hosting we plan three environments: production, test and development, at about 1,000 euros a month each. That is 3,000 euros a month, or 36,000 euros a year. On top of that come the SDLC and developer tools: CI/CD, repositories, testing and security scanning.</a:t>
+            </a:r>
+          </a:p>
         </p:txBody>
       </p:sp>
       <p:sp>
@@ -21020,7 +21026,7 @@
         <p:spPr>
           <a:xfrm>
             <a:off x="548640" y="4572000"/>
-            <a:ext cx="5440680" cy="1691640"/>
+            <a:ext cx="3566160" cy="1691640"/>
           </a:xfrm>
           <a:prstGeom prst="roundRect">
             <a:avLst>
@@ -21109,8 +21115,8 @@
         </p:nvSpPr>
         <p:spPr>
           <a:xfrm>
-            <a:off x="914400" y="4709160"/>
-            <a:ext cx="4846320" cy="685800"/>
+            <a:off x="868680" y="4663440"/>
+            <a:ext cx="3108960" cy="548640"/>
           </a:xfrm>
           <a:prstGeom prst="rect">
             <a:avLst/>
@@ -21129,7 +21135,7 @@
               </a:lnSpc>
             </a:pPr>
             <a:r>
-              <a:rPr sz="3400" b="1">
+              <a:rPr sz="2600" b="1">
                 <a:solidFill>
                   <a:srgbClr val="FFFFFF"/>
                 </a:solidFill>
@@ -21148,8 +21154,8 @@
         </p:nvSpPr>
         <p:spPr>
           <a:xfrm>
-            <a:off x="914400" y="5440680"/>
-            <a:ext cx="4846320" cy="365760"/>
+            <a:off x="868680" y="5230368"/>
+            <a:ext cx="3108960" cy="320040"/>
           </a:xfrm>
           <a:prstGeom prst="rect">
             <a:avLst/>
@@ -21168,7 +21174,7 @@
               </a:lnSpc>
             </a:pPr>
             <a:r>
-              <a:rPr sz="1600" b="1">
+              <a:rPr sz="1500" b="1">
                 <a:solidFill>
                   <a:srgbClr val="E6A817"/>
                 </a:solidFill>
@@ -21187,8 +21193,137 @@
         </p:nvSpPr>
         <p:spPr>
           <a:xfrm>
-            <a:off x="914400" y="5806440"/>
-            <a:ext cx="4846320" cy="365760"/>
+            <a:off x="868680" y="5559552"/>
+            <a:ext cx="3108960" cy="640080"/>
+          </a:xfrm>
+          <a:prstGeom prst="rect">
+            <a:avLst/>
+          </a:prstGeom>
+          <a:noFill/>
+        </p:spPr>
+        <p:txBody>
+          <a:bodyPr wrap="square" lIns="0" rIns="0" tIns="0" bIns="0">
+            <a:spAutoFit/>
+          </a:bodyPr>
+          <a:lstStyle/>
+          <a:p>
+            <a:pPr>
+              <a:lnSpc>
+                <a:spcPct val="105000"/>
+              </a:lnSpc>
+            </a:pPr>
+            <a:r>
+              <a:rPr sz="1200" b="0">
+                <a:solidFill>
+                  <a:srgbClr val="FFFFFF"/>
+                </a:solidFill>
+                <a:latin typeface="Calibri"/>
+              </a:rPr>
+              <a:t>Engineering and onboarding.</a:t>
+            </a:r>
+          </a:p>
+        </p:txBody>
+      </p:sp>
+      <p:sp>
+        <p:nvSpPr>
+          <p:cNvPr id="38" name="Rounded Rectangle 37"/>
+          <p:cNvSpPr/>
+          <p:nvPr/>
+        </p:nvSpPr>
+        <p:spPr>
+          <a:xfrm>
+            <a:off x="4315968" y="4572000"/>
+            <a:ext cx="3566160" cy="1691640"/>
+          </a:xfrm>
+          <a:prstGeom prst="roundRect">
+            <a:avLst>
+              <a:gd name="adj" fmla="val 5000"/>
+            </a:avLst>
+          </a:prstGeom>
+          <a:solidFill>
+            <a:srgbClr val="143D59"/>
+          </a:solidFill>
+          <a:ln>
+            <a:noFill/>
+          </a:ln>
+          <a:effectLst/>
+        </p:spPr>
+        <p:style>
+          <a:lnRef idx="1">
+            <a:schemeClr val="accent1"/>
+          </a:lnRef>
+          <a:fillRef idx="3">
+            <a:schemeClr val="accent1"/>
+          </a:fillRef>
+          <a:effectRef idx="2">
+            <a:schemeClr val="accent1"/>
+          </a:effectRef>
+          <a:fontRef idx="minor">
+            <a:schemeClr val="lt1"/>
+          </a:fontRef>
+        </p:style>
+        <p:txBody>
+          <a:bodyPr rtlCol="0" anchor="ctr"/>
+          <a:lstStyle/>
+          <a:p>
+            <a:pPr algn="ctr"/>
+          </a:p>
+        </p:txBody>
+      </p:sp>
+      <p:sp>
+        <p:nvSpPr>
+          <p:cNvPr id="39" name="Rectangle 38"/>
+          <p:cNvSpPr/>
+          <p:nvPr/>
+        </p:nvSpPr>
+        <p:spPr>
+          <a:xfrm>
+            <a:off x="4315968" y="4572000"/>
+            <a:ext cx="109728" cy="1691640"/>
+          </a:xfrm>
+          <a:prstGeom prst="rect">
+            <a:avLst/>
+          </a:prstGeom>
+          <a:solidFill>
+            <a:srgbClr val="C31E2E"/>
+          </a:solidFill>
+          <a:ln>
+            <a:noFill/>
+          </a:ln>
+          <a:effectLst/>
+        </p:spPr>
+        <p:style>
+          <a:lnRef idx="1">
+            <a:schemeClr val="accent1"/>
+          </a:lnRef>
+          <a:fillRef idx="3">
+            <a:schemeClr val="accent1"/>
+          </a:fillRef>
+          <a:effectRef idx="2">
+            <a:schemeClr val="accent1"/>
+          </a:effectRef>
+          <a:fontRef idx="minor">
+            <a:schemeClr val="lt1"/>
+          </a:fontRef>
+        </p:style>
+        <p:txBody>
+          <a:bodyPr rtlCol="0" anchor="ctr"/>
+          <a:lstStyle/>
+          <a:p>
+            <a:pPr algn="ctr"/>
+          </a:p>
+        </p:txBody>
+      </p:sp>
+      <p:sp>
+        <p:nvSpPr>
+          <p:cNvPr id="40" name="TextBox 39"/>
+          <p:cNvSpPr txBox="1"/>
+          <p:nvPr/>
+        </p:nvSpPr>
+        <p:spPr>
+          <a:xfrm>
+            <a:off x="4636007" y="4663440"/>
+            <a:ext cx="3108960" cy="548640"/>
           </a:xfrm>
           <a:prstGeom prst="rect">
             <a:avLst/>
@@ -21207,27 +21342,105 @@
               </a:lnSpc>
             </a:pPr>
             <a:r>
-              <a:rPr sz="1300" b="0">
+              <a:rPr sz="2600" b="1">
                 <a:solidFill>
                   <a:srgbClr val="FFFFFF"/>
                 </a:solidFill>
                 <a:latin typeface="Calibri"/>
               </a:rPr>
-              <a:t>Engineering, hosting, onboarding.</a:t>
-            </a:r>
-          </a:p>
-        </p:txBody>
-      </p:sp>
-      <p:sp>
-        <p:nvSpPr>
-          <p:cNvPr id="38" name="Rounded Rectangle 37"/>
+              <a:t>15 – 25% a year</a:t>
+            </a:r>
+          </a:p>
+        </p:txBody>
+      </p:sp>
+      <p:sp>
+        <p:nvSpPr>
+          <p:cNvPr id="41" name="TextBox 40"/>
+          <p:cNvSpPr txBox="1"/>
+          <p:nvPr/>
+        </p:nvSpPr>
+        <p:spPr>
+          <a:xfrm>
+            <a:off x="4636007" y="5230368"/>
+            <a:ext cx="3108960" cy="320040"/>
+          </a:xfrm>
+          <a:prstGeom prst="rect">
+            <a:avLst/>
+          </a:prstGeom>
+          <a:noFill/>
+        </p:spPr>
+        <p:txBody>
+          <a:bodyPr wrap="square" lIns="0" rIns="0" tIns="0" bIns="0">
+            <a:spAutoFit/>
+          </a:bodyPr>
+          <a:lstStyle/>
+          <a:p>
+            <a:pPr>
+              <a:lnSpc>
+                <a:spcPct val="100000"/>
+              </a:lnSpc>
+            </a:pPr>
+            <a:r>
+              <a:rPr sz="1500" b="1">
+                <a:solidFill>
+                  <a:srgbClr val="E6A817"/>
+                </a:solidFill>
+                <a:latin typeface="Calibri"/>
+              </a:rPr>
+              <a:t>To operate it</a:t>
+            </a:r>
+          </a:p>
+        </p:txBody>
+      </p:sp>
+      <p:sp>
+        <p:nvSpPr>
+          <p:cNvPr id="42" name="TextBox 41"/>
+          <p:cNvSpPr txBox="1"/>
+          <p:nvPr/>
+        </p:nvSpPr>
+        <p:spPr>
+          <a:xfrm>
+            <a:off x="4636007" y="5559552"/>
+            <a:ext cx="3108960" cy="640080"/>
+          </a:xfrm>
+          <a:prstGeom prst="rect">
+            <a:avLst/>
+          </a:prstGeom>
+          <a:noFill/>
+        </p:spPr>
+        <p:txBody>
+          <a:bodyPr wrap="square" lIns="0" rIns="0" tIns="0" bIns="0">
+            <a:spAutoFit/>
+          </a:bodyPr>
+          <a:lstStyle/>
+          <a:p>
+            <a:pPr>
+              <a:lnSpc>
+                <a:spcPct val="105000"/>
+              </a:lnSpc>
+            </a:pPr>
+            <a:r>
+              <a:rPr sz="1200" b="0">
+                <a:solidFill>
+                  <a:srgbClr val="FFFFFF"/>
+                </a:solidFill>
+                <a:latin typeface="Calibri"/>
+              </a:rPr>
+              <a:t>Of the build cost: about €120,000 – 375,000 a year.</a:t>
+            </a:r>
+          </a:p>
+        </p:txBody>
+      </p:sp>
+      <p:sp>
+        <p:nvSpPr>
+          <p:cNvPr id="43" name="Rounded Rectangle 42"/>
           <p:cNvSpPr/>
           <p:nvPr/>
         </p:nvSpPr>
         <p:spPr>
           <a:xfrm>
-            <a:off x="6199631" y="4572000"/>
-            <a:ext cx="5440680" cy="1691640"/>
+            <a:off x="8083296" y="4572000"/>
+            <a:ext cx="3566160" cy="1691640"/>
           </a:xfrm>
           <a:prstGeom prst="roundRect">
             <a:avLst>
@@ -21266,20 +21479,20 @@
       </p:sp>
       <p:sp>
         <p:nvSpPr>
-          <p:cNvPr id="39" name="Rectangle 38"/>
+          <p:cNvPr id="44" name="Rectangle 43"/>
           <p:cNvSpPr/>
           <p:nvPr/>
         </p:nvSpPr>
         <p:spPr>
           <a:xfrm>
-            <a:off x="6199631" y="4572000"/>
+            <a:off x="8083296" y="4572000"/>
             <a:ext cx="109728" cy="1691640"/>
           </a:xfrm>
           <a:prstGeom prst="rect">
             <a:avLst/>
           </a:prstGeom>
           <a:solidFill>
-            <a:srgbClr val="C31E2E"/>
+            <a:srgbClr val="E6A817"/>
           </a:solidFill>
           <a:ln>
             <a:noFill/>
@@ -21310,14 +21523,14 @@
       </p:sp>
       <p:sp>
         <p:nvSpPr>
-          <p:cNvPr id="40" name="TextBox 39"/>
+          <p:cNvPr id="45" name="TextBox 44"/>
           <p:cNvSpPr txBox="1"/>
           <p:nvPr/>
         </p:nvSpPr>
         <p:spPr>
           <a:xfrm>
-            <a:off x="6565392" y="4709160"/>
-            <a:ext cx="4846320" cy="685800"/>
+            <a:off x="8403336" y="4663440"/>
+            <a:ext cx="3108960" cy="548640"/>
           </a:xfrm>
           <a:prstGeom prst="rect">
             <a:avLst/>
@@ -21336,27 +21549,27 @@
               </a:lnSpc>
             </a:pPr>
             <a:r>
-              <a:rPr sz="3400" b="1">
+              <a:rPr sz="2600" b="1">
                 <a:solidFill>
                   <a:srgbClr val="FFFFFF"/>
                 </a:solidFill>
                 <a:latin typeface="Calibri"/>
               </a:rPr>
-              <a:t>15 – 25% per year</a:t>
-            </a:r>
-          </a:p>
-        </p:txBody>
-      </p:sp>
-      <p:sp>
-        <p:nvSpPr>
-          <p:cNvPr id="41" name="TextBox 40"/>
+              <a:t>€3,000 a month</a:t>
+            </a:r>
+          </a:p>
+        </p:txBody>
+      </p:sp>
+      <p:sp>
+        <p:nvSpPr>
+          <p:cNvPr id="46" name="TextBox 45"/>
           <p:cNvSpPr txBox="1"/>
           <p:nvPr/>
         </p:nvSpPr>
         <p:spPr>
           <a:xfrm>
-            <a:off x="6565392" y="5440680"/>
-            <a:ext cx="4846320" cy="365760"/>
+            <a:off x="8403336" y="5230368"/>
+            <a:ext cx="3108960" cy="320040"/>
           </a:xfrm>
           <a:prstGeom prst="rect">
             <a:avLst/>
@@ -21375,27 +21588,27 @@
               </a:lnSpc>
             </a:pPr>
             <a:r>
-              <a:rPr sz="1600" b="1">
+              <a:rPr sz="1500" b="1">
                 <a:solidFill>
                   <a:srgbClr val="E6A817"/>
                 </a:solidFill>
                 <a:latin typeface="Calibri"/>
               </a:rPr>
-              <a:t>To operate it</a:t>
-            </a:r>
-          </a:p>
-        </p:txBody>
-      </p:sp>
-      <p:sp>
-        <p:nvSpPr>
-          <p:cNvPr id="42" name="TextBox 41"/>
+              <a:t>Hosting: prod, test and dev</a:t>
+            </a:r>
+          </a:p>
+        </p:txBody>
+      </p:sp>
+      <p:sp>
+        <p:nvSpPr>
+          <p:cNvPr id="47" name="TextBox 46"/>
           <p:cNvSpPr txBox="1"/>
           <p:nvPr/>
         </p:nvSpPr>
         <p:spPr>
           <a:xfrm>
-            <a:off x="6565392" y="5806440"/>
-            <a:ext cx="4846320" cy="365760"/>
+            <a:off x="8403336" y="5559552"/>
+            <a:ext cx="3108960" cy="640080"/>
           </a:xfrm>
           <a:prstGeom prst="rect">
             <a:avLst/>
@@ -21410,24 +21623,24 @@
           <a:p>
             <a:pPr>
               <a:lnSpc>
-                <a:spcPct val="100000"/>
+                <a:spcPct val="105000"/>
               </a:lnSpc>
             </a:pPr>
             <a:r>
-              <a:rPr sz="1300" b="0">
+              <a:rPr sz="1200" b="0">
                 <a:solidFill>
                   <a:srgbClr val="FFFFFF"/>
                 </a:solidFill>
                 <a:latin typeface="Calibri"/>
               </a:rPr>
-              <a:t>About €120,000 – 375,000 a year.</a:t>
-            </a:r>
-          </a:p>
-        </p:txBody>
-      </p:sp>
-      <p:sp>
-        <p:nvSpPr>
-          <p:cNvPr id="43" name="TextBox 42"/>
+              <a:t>€1,000 per environment, €36,000 a year. Plus SDLC and developer tools.</a:t>
+            </a:r>
+          </a:p>
+        </p:txBody>
+      </p:sp>
+      <p:sp>
+        <p:nvSpPr>
+          <p:cNvPr id="48" name="TextBox 47"/>
           <p:cNvSpPr txBox="1"/>
           <p:nvPr/>
         </p:nvSpPr>

</xml_diff>